<commit_message>
feat: make the data tier genuinely Multi-AZ (primary AZ-a + standby AZ-b)
- Launched a second simulated-DB node (data-db-1b) in data-subnet-1b (us-east-1b).
- App now tries the primary and fails over to the standby; /health reports db_active,
  db_primary, db_standby. Verified: stopping the primary flips all app instances to the
  standby with db:up, and they fail back on recovery (tests/test-results.md).
- Rebaked launch template (v2) with both DB hosts + new app; rolled out via ASG instance refresh.
- Updated manage.sh (stop/start both data nodes), all diagrams (PNG/HTML/pptx), and docs.

Co-Authored-By: Claude Opus 4.8 <noreply@anthropic.com>
</commit_message>
<xml_diff>
--- a/presentation/three-tier-slides.pptx
+++ b/presentation/three-tier-slides.pptx
@@ -2501,7 +2501,7 @@
                 <a:ea typeface="Arial" pitchFamily="34" charset="-122"/>
                 <a:cs typeface="Arial" pitchFamily="34" charset="-120"/>
               </a:rPr>
-              <a:t>Data DB  ·  data-subnet-1a</a:t>
+              <a:t>Data DB primary  ·  data-subnet-1a</a:t>
             </a:r>
             <a:pPr algn="ctr" indent="0" marL="0">
               <a:buNone/>
@@ -2521,7 +2521,7 @@
                 <a:ea typeface="Arial" pitchFamily="34" charset="-122"/>
                 <a:cs typeface="Arial" pitchFamily="34" charset="-120"/>
               </a:rPr>
-              <a:t>simulated :3306 · isolated (no internet)</a:t>
+              <a:t>10.0.21.110:3306 · simulated · isolated</a:t>
             </a:r>
             <a:endParaRPr lang="en-US" sz="1250" dirty="0"/>
           </a:p>
@@ -2587,7 +2587,7 @@
                 <a:ea typeface="Arial" pitchFamily="34" charset="-122"/>
                 <a:cs typeface="Arial" pitchFamily="34" charset="-120"/>
               </a:rPr>
-              <a:t>Data standby  ·  data-subnet-1b</a:t>
+              <a:t>Data DB standby  ·  data-subnet-1b</a:t>
             </a:r>
             <a:pPr algn="ctr" indent="0" marL="0">
               <a:buNone/>
@@ -2607,7 +2607,7 @@
                 <a:ea typeface="Arial" pitchFamily="34" charset="-122"/>
                 <a:cs typeface="Arial" pitchFamily="34" charset="-120"/>
               </a:rPr>
-              <a:t>route table: local only</a:t>
+              <a:t>10.0.22.147:3306 · app fails over here</a:t>
             </a:r>
             <a:endParaRPr lang="en-US" sz="1250" dirty="0"/>
           </a:p>

</xml_diff>